<commit_message>
docs(orgcomp-series): register the IAM Governance Kit series home as Vol IX Book 06
Decides #1221's series-home question: Identity & Access Governance lands as
Vol IX Book 06 (book-day2-iam, slot IX-06), registered in the compliance
spine with its control contract (AC-2, AC-5, AC-6, IA-4, IA-5, AU-2 —
event-driven JML, certification campaigns, IAM evidence feed). The kit
realization stays gated on the requirements v0.9 -> v1.0 sign-off, stated in
the book and the spine comment. Volume IX overview, exec-summary designation
and link tables, crosswalk prose counts, sidebar, and derived files updated;
Book 00 deck/docx derivatives re-issued at the new Date Code. Book 06's own
DOCX/PPTX derivatives follow on the next authoring pass (no Quarto in this
environment).

Co-Authored-By: Claude Fable 5 <noreply@anthropic.com>
Claude-Session: https://claude.ai/code/session_01N5UTDTQvE1TzezbTuWtxxZ
</commit_message>
<xml_diff>
--- a/docs/customer-documents/orgcomp-series/Vol_IX_Book_00_OrgComp_Day2_Operations_Overview.pptx
+++ b/docs/customer-documents/orgcomp-series/Vol_IX_Book_00_OrgComp_Day2_Operations_Overview.pptx
@@ -512,7 +512,7 @@
           <a:p/>
           <a:p>
             <a:r>
-              <a:t>Vendor sources: host repo: docs/customer-documents/federal-aan-series/servicenow-day2/</a:t>
+              <a:t>Vendor sources: host repo: docs/customer-documents/orgcomp-series/servicenow-day2/</a:t>
             </a:r>
           </a:p>
         </p:txBody>
@@ -4563,7 +4563,7 @@
                 </a:solidFill>
                 <a:latin typeface="Arial"/>
               </a:rPr>
-              <a:t>Date Code: 2026-07-12 15:00 ET</a:t>
+              <a:t>Date Code: 2026-07-19 12:10 ET</a:t>
             </a:r>
           </a:p>
         </p:txBody>
@@ -4751,7 +4751,7 @@
                 </a:solidFill>
                 <a:latin typeface="Arial"/>
               </a:rPr>
-              <a:t>ServiceNow Day-2 Operations · Date Code: 2026-07-12 15:00 ET</a:t>
+              <a:t>ServiceNow Day-2 Operations · Date Code: 2026-07-19 12:10 ET</a:t>
             </a:r>
           </a:p>
         </p:txBody>
@@ -4974,7 +4974,7 @@
                 </a:solidFill>
                 <a:latin typeface="Arial"/>
               </a:rPr>
-              <a:t>ServiceNow Day-2 Operations · Date Code: 2026-07-12 15:00 ET</a:t>
+              <a:t>ServiceNow Day-2 Operations · Date Code: 2026-07-19 12:10 ET</a:t>
             </a:r>
           </a:p>
         </p:txBody>
@@ -5846,7 +5846,7 @@
                 </a:solidFill>
                 <a:latin typeface="Arial"/>
               </a:rPr>
-              <a:t>Five books across the day-2 surface</a:t>
+              <a:t>Six books across the day-2 surface</a:t>
             </a:r>
           </a:p>
         </p:txBody>
@@ -5881,7 +5881,7 @@
                 </a:solidFill>
                 <a:latin typeface="Arial"/>
               </a:rPr>
-              <a:t>ServiceNow Day-2 Operations · Date Code: 2026-07-12 15:00 ET</a:t>
+              <a:t>ServiceNow Day-2 Operations · Date Code: 2026-07-19 12:10 ET</a:t>
             </a:r>
           </a:p>
         </p:txBody>
@@ -5944,7 +5944,7 @@
                 <a:gridCol w="2743200"/>
                 <a:gridCol w="2743200"/>
               </a:tblGrid>
-              <a:tr h="457200">
+              <a:tr h="391885">
                 <a:tc>
                   <a:txBody>
                     <a:bodyPr/>
@@ -6012,7 +6012,7 @@
                   </a:tcPr>
                 </a:tc>
               </a:tr>
-              <a:tr h="457200">
+              <a:tr h="391885">
                 <a:tc>
                   <a:txBody>
                     <a:bodyPr/>
@@ -6080,7 +6080,7 @@
                   </a:tcPr>
                 </a:tc>
               </a:tr>
-              <a:tr h="457200">
+              <a:tr h="391885">
                 <a:tc>
                   <a:txBody>
                     <a:bodyPr/>
@@ -6148,7 +6148,7 @@
                   </a:tcPr>
                 </a:tc>
               </a:tr>
-              <a:tr h="457200">
+              <a:tr h="391885">
                 <a:tc>
                   <a:txBody>
                     <a:bodyPr/>
@@ -6216,7 +6216,7 @@
                   </a:tcPr>
                 </a:tc>
               </a:tr>
-              <a:tr h="457200">
+              <a:tr h="391885">
                 <a:tc>
                   <a:txBody>
                     <a:bodyPr/>
@@ -6284,7 +6284,7 @@
                   </a:tcPr>
                 </a:tc>
               </a:tr>
-              <a:tr h="457200">
+              <a:tr h="391885">
                 <a:tc>
                   <a:txBody>
                     <a:bodyPr/>
@@ -6352,6 +6352,74 @@
                   </a:tcPr>
                 </a:tc>
               </a:tr>
+              <a:tr h="391890">
+                <a:tc>
+                  <a:txBody>
+                    <a:bodyPr/>
+                    <a:lstStyle/>
+                    <a:p>
+                      <a:r>
+                        <a:rPr sz="900" b="1">
+                          <a:solidFill>
+                            <a:srgbClr val="1F3A5F"/>
+                          </a:solidFill>
+                          <a:latin typeface="Arial"/>
+                        </a:rPr>
+                        <a:t>IX-06</a:t>
+                      </a:r>
+                    </a:p>
+                  </a:txBody>
+                  <a:tcPr anchor="ctr">
+                    <a:solidFill>
+                      <a:srgbClr val="E6F5F2"/>
+                    </a:solidFill>
+                  </a:tcPr>
+                </a:tc>
+                <a:tc>
+                  <a:txBody>
+                    <a:bodyPr/>
+                    <a:lstStyle/>
+                    <a:p>
+                      <a:r>
+                        <a:rPr sz="900">
+                          <a:solidFill>
+                            <a:srgbClr val="1E293B"/>
+                          </a:solidFill>
+                          <a:latin typeface="Arial"/>
+                        </a:rPr>
+                        <a:t>Identity &amp; Access Governance — event-driven JML, certification campaigns, IAM evidence (gated)</a:t>
+                      </a:r>
+                    </a:p>
+                  </a:txBody>
+                  <a:tcPr anchor="ctr">
+                    <a:solidFill>
+                      <a:srgbClr val="E6F5F2"/>
+                    </a:solidFill>
+                  </a:tcPr>
+                </a:tc>
+                <a:tc>
+                  <a:txBody>
+                    <a:bodyPr/>
+                    <a:lstStyle/>
+                    <a:p>
+                      <a:r>
+                        <a:rPr sz="900">
+                          <a:solidFill>
+                            <a:srgbClr val="1E293B"/>
+                          </a:solidFill>
+                          <a:latin typeface="Arial"/>
+                        </a:rPr>
+                        <a:t>Phase 2 · #1221</a:t>
+                      </a:r>
+                    </a:p>
+                  </a:txBody>
+                  <a:tcPr anchor="ctr">
+                    <a:solidFill>
+                      <a:srgbClr val="E6F5F2"/>
+                    </a:solidFill>
+                  </a:tcPr>
+                </a:tc>
+              </a:tr>
             </a:tbl>
           </a:graphicData>
         </a:graphic>
@@ -6539,7 +6607,7 @@
                 </a:solidFill>
                 <a:latin typeface="Arial"/>
               </a:rPr>
-              <a:t>ServiceNow Day-2 Operations · Date Code: 2026-07-12 15:00 ET</a:t>
+              <a:t>ServiceNow Day-2 Operations · Date Code: 2026-07-19 12:10 ET</a:t>
             </a:r>
           </a:p>
         </p:txBody>

</xml_diff>

<commit_message>
docs(orgcomp-series): bring the Vol IX volume map up to Books 05-06
The volume-map figure stopped at Book 04 (it predated Books 05 and 06). The
bottom row now carries Teams Telephony, SaaS Integration Governance, and
Identity & Access Governance (Kit Phase 2, gated) plus a condensed
evidence-join panel; section header and fig-alt rewritten to match. Book 00
re-dated; pptx rebuilt from the deck spec and the docx patched in place
(date + embedded volume-map image swap).

Co-Authored-By: Claude Fable 5 <noreply@anthropic.com>
Claude-Session: https://claude.ai/code/session_01N5UTDTQvE1TzezbTuWtxxZ
</commit_message>
<xml_diff>
--- a/docs/customer-documents/orgcomp-series/Vol_IX_Book_00_OrgComp_Day2_Operations_Overview.pptx
+++ b/docs/customer-documents/orgcomp-series/Vol_IX_Book_00_OrgComp_Day2_Operations_Overview.pptx
@@ -4563,7 +4563,7 @@
                 </a:solidFill>
                 <a:latin typeface="Arial"/>
               </a:rPr>
-              <a:t>Date Code: 2026-07-19 16:20 ET</a:t>
+              <a:t>Date Code: 2026-07-19 17:05 ET</a:t>
             </a:r>
           </a:p>
         </p:txBody>
@@ -4751,7 +4751,7 @@
                 </a:solidFill>
                 <a:latin typeface="Arial"/>
               </a:rPr>
-              <a:t>ServiceNow Day-2 Operations · Date Code: 2026-07-19 16:20 ET</a:t>
+              <a:t>ServiceNow Day-2 Operations · Date Code: 2026-07-19 17:05 ET</a:t>
             </a:r>
           </a:p>
         </p:txBody>
@@ -4974,7 +4974,7 @@
                 </a:solidFill>
                 <a:latin typeface="Arial"/>
               </a:rPr>
-              <a:t>ServiceNow Day-2 Operations · Date Code: 2026-07-19 16:20 ET</a:t>
+              <a:t>ServiceNow Day-2 Operations · Date Code: 2026-07-19 17:05 ET</a:t>
             </a:r>
           </a:p>
         </p:txBody>
@@ -5881,7 +5881,7 @@
                 </a:solidFill>
                 <a:latin typeface="Arial"/>
               </a:rPr>
-              <a:t>ServiceNow Day-2 Operations · Date Code: 2026-07-19 16:20 ET</a:t>
+              <a:t>ServiceNow Day-2 Operations · Date Code: 2026-07-19 17:05 ET</a:t>
             </a:r>
           </a:p>
         </p:txBody>
@@ -6607,7 +6607,7 @@
                 </a:solidFill>
                 <a:latin typeface="Arial"/>
               </a:rPr>
-              <a:t>ServiceNow Day-2 Operations · Date Code: 2026-07-19 16:20 ET</a:t>
+              <a:t>ServiceNow Day-2 Operations · Date Code: 2026-07-19 17:05 ET</a:t>
             </a:r>
           </a:p>
         </p:txBody>

</xml_diff>